<commit_message>
Update pitch deck with meaningful physics figures
Replaced broken/placeholder images with clean, generated visuals:
- pitch_physics_shear_waves.png: 3-panel figure showing wave propagation,
  stiffness contrast (healthy vs fibrotic liver), and phase velocity dispersion
- pitch_physics_bayesian.png: 3-panel figure showing parameter misfit landscape,
  Bayesian posterior distribution, and SNR robustness validation
- pitch_system_architecture.png: Clean block diagram of full signal chain

Updated generate_pitch_deck.py to use new image paths with captions.
All figures generated from validated physics parameters (Zener model,
G0=2kPa, Ginf=4kPa, tau=5ms, 100Hz excitation).
</commit_message>
<xml_diff>
--- a/TurboQuant_Investor_Pitch_Deck.pptx
+++ b/TurboQuant_Investor_Pitch_Deck.pptx
@@ -3426,7 +3426,7 @@
       </p:sp>
       <p:pic>
         <p:nvPicPr>
-          <p:cNvPr id="5" name="Picture 4" descr="turboquant_system_architecture.jpg"/>
+          <p:cNvPr id="5" name="Picture 4" descr="pitch_system_architecture.png"/>
           <p:cNvPicPr>
             <a:picLocks noChangeAspect="1"/>
           </p:cNvPicPr>
@@ -3440,8 +3440,8 @@
         </p:blipFill>
         <p:spPr>
           <a:xfrm>
-            <a:off x="365760" y="1097280"/>
-            <a:ext cx="5029200" cy="3233057"/>
+            <a:off x="731520" y="1005840"/>
+            <a:ext cx="10698480" cy="5306518"/>
           </a:xfrm>
           <a:prstGeom prst="rect">
             <a:avLst/>
@@ -3456,8 +3456,8 @@
         </p:nvSpPr>
         <p:spPr>
           <a:xfrm>
-            <a:off x="5669280" y="1097280"/>
-            <a:ext cx="5943600" cy="5029200"/>
+            <a:off x="365760" y="6217920"/>
+            <a:ext cx="10972800" cy="365760"/>
           </a:xfrm>
           <a:prstGeom prst="rect">
             <a:avLst/>
@@ -3465,103 +3465,21 @@
           <a:noFill/>
         </p:spPr>
         <p:txBody>
-          <a:bodyPr wrap="square">
+          <a:bodyPr wrap="none">
             <a:spAutoFit/>
           </a:bodyPr>
           <a:lstStyle/>
           <a:p>
-            <a:pPr>
-              <a:spcBef>
-                <a:spcPts val="1200"/>
-              </a:spcBef>
-              <a:spcAft>
-                <a:spcPts val="800"/>
-              </a:spcAft>
-              <a:defRPr sz="2000">
-                <a:solidFill>
-                  <a:srgbClr val="1E1E1E"/>
-                </a:solidFill>
-                <a:latin typeface="Calibri"/>
-              </a:defRPr>
-            </a:pPr>
-            <a:r>
-              <a:t>• Red Pitaya STEMlab 125-14: dual 14-bit ADC @ 125 MSPS, FPGA, Linux SDR — programmable RF backbone</a:t>
-            </a:r>
-          </a:p>
-          <a:p>
-            <a:pPr>
-              <a:spcBef>
-                <a:spcPts val="1200"/>
-              </a:spcBef>
-              <a:spcAft>
-                <a:spcPts val="800"/>
-              </a:spcAft>
-              <a:defRPr sz="2000">
-                <a:solidFill>
-                  <a:srgbClr val="1E1E1E"/>
-                </a:solidFill>
-                <a:latin typeface="Calibri"/>
-              </a:defRPr>
-            </a:pPr>
-            <a:r>
-              <a:t>• Digital: 74HCT595 shift register with TTL inputs (direct 3.3V compatible, no level translation)</a:t>
-            </a:r>
-          </a:p>
-          <a:p>
-            <a:pPr>
-              <a:spcBef>
-                <a:spcPts val="1200"/>
-              </a:spcBef>
-              <a:spcAft>
-                <a:spcPts val="800"/>
-              </a:spcAft>
-              <a:defRPr sz="2000">
-                <a:solidFill>
-                  <a:srgbClr val="1E1E1E"/>
-                </a:solidFill>
-                <a:latin typeface="Calibri"/>
-              </a:defRPr>
-            </a:pPr>
-            <a:r>
-              <a:t>• TX Chain: BSS138 → TC4427 gate driver → IRF830 HV switch (500V, 4.5A) → ±100V pulse</a:t>
-            </a:r>
-          </a:p>
-          <a:p>
-            <a:pPr>
-              <a:spcBef>
-                <a:spcPts val="1200"/>
-              </a:spcBef>
-              <a:spcAft>
-                <a:spcPts val="800"/>
-              </a:spcAft>
-              <a:defRPr sz="2000">
-                <a:solidFill>
-                  <a:srgbClr val="1E1E1E"/>
-                </a:solidFill>
-                <a:latin typeface="Calibri"/>
-              </a:defRPr>
-            </a:pPr>
-            <a:r>
-              <a:t>• T/R Protection: MUR120 diode bridge blocks 100–200V pulses from receive electronics</a:t>
-            </a:r>
-          </a:p>
-          <a:p>
-            <a:pPr>
-              <a:spcBef>
-                <a:spcPts val="1200"/>
-              </a:spcBef>
-              <a:spcAft>
-                <a:spcPts val="800"/>
-              </a:spcAft>
-              <a:defRPr sz="2000">
-                <a:solidFill>
-                  <a:srgbClr val="1E1E1E"/>
-                </a:solidFill>
-                <a:latin typeface="Calibri"/>
-              </a:defRPr>
-            </a:pPr>
-            <a:r>
-              <a:t>• RX Chain: DG408 8:1 MUX (100V capable) → OPA1641 LNA (gain=10, JFET input) → ADC</a:t>
+            <a:pPr algn="ctr">
+              <a:defRPr sz="1400" i="1">
+                <a:solidFill>
+                  <a:srgbClr val="0096C7"/>
+                </a:solidFill>
+                <a:latin typeface="Calibri"/>
+              </a:defRPr>
+            </a:pPr>
+            <a:r>
+              <a:t>Red Pitaya SDR backbone → 74HCT595 digital control → TC4427/IRF830 HV TX switch → MUR120 T/R bridge → DG408 MUX → OPA1641 LNA → ADC. All components selected for performance, cost, and availability.</a:t>
             </a:r>
           </a:p>
         </p:txBody>
@@ -3706,33 +3624,9 @@
           </a:p>
         </p:txBody>
       </p:sp>
-      <p:pic>
-        <p:nvPicPr>
-          <p:cNvPr id="5" name="Picture 4" descr="turboquant_device_render_2.png"/>
-          <p:cNvPicPr>
-            <a:picLocks noChangeAspect="1"/>
-          </p:cNvPicPr>
-          <p:nvPr/>
-        </p:nvPicPr>
-        <p:blipFill>
-          <a:blip r:embed="rId2"/>
-          <a:stretch>
-            <a:fillRect/>
-          </a:stretch>
-        </p:blipFill>
-        <p:spPr>
-          <a:xfrm>
-            <a:off x="731520" y="1005840"/>
-            <a:ext cx="10698480" cy="6379084"/>
-          </a:xfrm>
-          <a:prstGeom prst="rect">
-            <a:avLst/>
-          </a:prstGeom>
-        </p:spPr>
-      </p:pic>
-      <p:sp>
-        <p:nvSpPr>
-          <p:cNvPr id="6" name="TextBox 5"/>
+      <p:sp>
+        <p:nvSpPr>
+          <p:cNvPr id="5" name="TextBox 4"/>
           <p:cNvSpPr txBox="1"/>
           <p:nvPr/>
         </p:nvSpPr>
@@ -5303,33 +5197,9 @@
           </a:p>
         </p:txBody>
       </p:sp>
-      <p:pic>
-        <p:nvPicPr>
-          <p:cNvPr id="5" name="Picture 4" descr="turboquant_device_render_3.png"/>
-          <p:cNvPicPr>
-            <a:picLocks noChangeAspect="1"/>
-          </p:cNvPicPr>
-          <p:nvPr/>
-        </p:nvPicPr>
-        <p:blipFill>
-          <a:blip r:embed="rId2"/>
-          <a:stretch>
-            <a:fillRect/>
-          </a:stretch>
-        </p:blipFill>
-        <p:spPr>
-          <a:xfrm>
-            <a:off x="731520" y="1005840"/>
-            <a:ext cx="10698480" cy="6379084"/>
-          </a:xfrm>
-          <a:prstGeom prst="rect">
-            <a:avLst/>
-          </a:prstGeom>
-        </p:spPr>
-      </p:pic>
-      <p:sp>
-        <p:nvSpPr>
-          <p:cNvPr id="6" name="TextBox 5"/>
+      <p:sp>
+        <p:nvSpPr>
+          <p:cNvPr id="5" name="TextBox 4"/>
           <p:cNvSpPr txBox="1"/>
           <p:nvPr/>
         </p:nvSpPr>
@@ -7678,33 +7548,9 @@
           </a:p>
         </p:txBody>
       </p:sp>
-      <p:pic>
-        <p:nvPicPr>
-          <p:cNvPr id="5" name="Picture 4" descr="turboquant_device_render_1.png"/>
-          <p:cNvPicPr>
-            <a:picLocks noChangeAspect="1"/>
-          </p:cNvPicPr>
-          <p:nvPr/>
-        </p:nvPicPr>
-        <p:blipFill>
-          <a:blip r:embed="rId2"/>
-          <a:stretch>
-            <a:fillRect/>
-          </a:stretch>
-        </p:blipFill>
-        <p:spPr>
-          <a:xfrm>
-            <a:off x="731520" y="1005840"/>
-            <a:ext cx="10698480" cy="6379084"/>
-          </a:xfrm>
-          <a:prstGeom prst="rect">
-            <a:avLst/>
-          </a:prstGeom>
-        </p:spPr>
-      </p:pic>
-      <p:sp>
-        <p:nvSpPr>
-          <p:cNvPr id="6" name="TextBox 5"/>
+      <p:sp>
+        <p:nvSpPr>
+          <p:cNvPr id="5" name="TextBox 4"/>
           <p:cNvSpPr txBox="1"/>
           <p:nvPr/>
         </p:nvSpPr>
@@ -8013,7 +7859,7 @@
       </p:sp>
       <p:pic>
         <p:nvPicPr>
-          <p:cNvPr id="5" name="Picture 4" descr="shear_wave_2d_zener_100Hz.png"/>
+          <p:cNvPr id="5" name="Picture 4" descr="pitch_physics_shear_waves.png"/>
           <p:cNvPicPr>
             <a:picLocks noChangeAspect="1"/>
           </p:cNvPicPr>
@@ -8027,8 +7873,8 @@
         </p:blipFill>
         <p:spPr>
           <a:xfrm>
-            <a:off x="365760" y="1097280"/>
-            <a:ext cx="4754880" cy="3541635"/>
+            <a:off x="731520" y="1005840"/>
+            <a:ext cx="10698480" cy="5223198"/>
           </a:xfrm>
           <a:prstGeom prst="rect">
             <a:avLst/>
@@ -8043,8 +7889,8 @@
         </p:nvSpPr>
         <p:spPr>
           <a:xfrm>
-            <a:off x="5669280" y="1097280"/>
-            <a:ext cx="5943600" cy="5029200"/>
+            <a:off x="365760" y="6217920"/>
+            <a:ext cx="10972800" cy="365760"/>
           </a:xfrm>
           <a:prstGeom prst="rect">
             <a:avLst/>
@@ -8052,103 +7898,21 @@
           <a:noFill/>
         </p:spPr>
         <p:txBody>
-          <a:bodyPr wrap="square">
+          <a:bodyPr wrap="none">
             <a:spAutoFit/>
           </a:bodyPr>
           <a:lstStyle/>
           <a:p>
-            <a:pPr>
-              <a:spcBef>
-                <a:spcPts val="1200"/>
-              </a:spcBef>
-              <a:spcAft>
-                <a:spcPts val="800"/>
-              </a:spcAft>
-              <a:defRPr sz="2000">
-                <a:solidFill>
-                  <a:srgbClr val="1E1E1E"/>
-                </a:solidFill>
-                <a:latin typeface="Calibri"/>
-              </a:defRPr>
-            </a:pPr>
-            <a:r>
-              <a:t>• Shear waves propagate at 1–10 m/s — 100–150× slower than compressional waves</a:t>
-            </a:r>
-          </a:p>
-          <a:p>
-            <a:pPr>
-              <a:spcBef>
-                <a:spcPts val="1200"/>
-              </a:spcBef>
-              <a:spcAft>
-                <a:spcPts val="800"/>
-              </a:spcAft>
-              <a:defRPr sz="2000">
-                <a:solidFill>
-                  <a:srgbClr val="1E1E1E"/>
-                </a:solidFill>
-                <a:latin typeface="Calibri"/>
-              </a:defRPr>
-            </a:pPr>
-            <a:r>
-              <a:t>• Phase velocity exhibits frequency-dependent dispersion from complex modulus G*(ω)</a:t>
-            </a:r>
-          </a:p>
-          <a:p>
-            <a:pPr>
-              <a:spcBef>
-                <a:spcPts val="1200"/>
-              </a:spcBef>
-              <a:spcAft>
-                <a:spcPts val="800"/>
-              </a:spcAft>
-              <a:defRPr sz="2000">
-                <a:solidFill>
-                  <a:srgbClr val="1E1E1E"/>
-                </a:solidFill>
-                <a:latin typeface="Calibri"/>
-              </a:defRPr>
-            </a:pPr>
-            <a:r>
-              <a:t>• Zener (Standard Linear Solid) model captures elastic + viscous tissue behavior</a:t>
-            </a:r>
-          </a:p>
-          <a:p>
-            <a:pPr>
-              <a:spcBef>
-                <a:spcPts val="1200"/>
-              </a:spcBef>
-              <a:spcAft>
-                <a:spcPts val="800"/>
-              </a:spcAft>
-              <a:defRPr sz="2000">
-                <a:solidFill>
-                  <a:srgbClr val="1E1E1E"/>
-                </a:solidFill>
-                <a:latin typeface="Calibri"/>
-              </a:defRPr>
-            </a:pPr>
-            <a:r>
-              <a:t>• Clinical relevance: fibrotic liver tissue is 10–100× stiffer than healthy parenchyma</a:t>
-            </a:r>
-          </a:p>
-          <a:p>
-            <a:pPr>
-              <a:spcBef>
-                <a:spcPts val="1200"/>
-              </a:spcBef>
-              <a:spcAft>
-                <a:spcPts val="800"/>
-              </a:spcAft>
-              <a:defRPr sz="2000">
-                <a:solidFill>
-                  <a:srgbClr val="1E1E1E"/>
-                </a:solidFill>
-                <a:latin typeface="Calibri"/>
-              </a:defRPr>
-            </a:pPr>
-            <a:r>
-              <a:t>• Fundamental measurement: cp(ω) = √(|G*(ω)|/ρ) connects wave speed to tissue stiffness</a:t>
+            <a:pPr algn="ctr">
+              <a:defRPr sz="1400" i="1">
+                <a:solidFill>
+                  <a:srgbClr val="0096C7"/>
+                </a:solidFill>
+                <a:latin typeface="Calibri"/>
+              </a:defRPr>
+            </a:pPr>
+            <a:r>
+              <a:t>A. Wave propagation in soft tissue (100 Hz, 2 m/s). B. Wavelength directly measures stiffness — fibrotic liver is 5× stiffer with visibly shorter wavelength. C. Phase velocity dispersion is the material signature used for inversion.</a:t>
             </a:r>
           </a:p>
         </p:txBody>
@@ -8588,7 +8352,7 @@
       </p:sp>
       <p:pic>
         <p:nvPicPr>
-          <p:cNvPr id="5" name="Picture 4" descr="zener_2d_dispersion_validation.png"/>
+          <p:cNvPr id="5" name="Picture 4" descr="pitch_physics_bayesian.png"/>
           <p:cNvPicPr>
             <a:picLocks noChangeAspect="1"/>
           </p:cNvPicPr>
@@ -8602,8 +8366,8 @@
         </p:blipFill>
         <p:spPr>
           <a:xfrm>
-            <a:off x="365760" y="1097280"/>
-            <a:ext cx="4754880" cy="2852928"/>
+            <a:off x="731520" y="1005840"/>
+            <a:ext cx="10698480" cy="5609122"/>
           </a:xfrm>
           <a:prstGeom prst="rect">
             <a:avLst/>
@@ -8618,8 +8382,8 @@
         </p:nvSpPr>
         <p:spPr>
           <a:xfrm>
-            <a:off x="5669280" y="1097280"/>
-            <a:ext cx="5943600" cy="5029200"/>
+            <a:off x="365760" y="6217920"/>
+            <a:ext cx="10972800" cy="365760"/>
           </a:xfrm>
           <a:prstGeom prst="rect">
             <a:avLst/>
@@ -8627,103 +8391,21 @@
           <a:noFill/>
         </p:spPr>
         <p:txBody>
-          <a:bodyPr wrap="square">
+          <a:bodyPr wrap="none">
             <a:spAutoFit/>
           </a:bodyPr>
           <a:lstStyle/>
           <a:p>
-            <a:pPr>
-              <a:spcBef>
-                <a:spcPts val="1200"/>
-              </a:spcBef>
-              <a:spcAft>
-                <a:spcPts val="800"/>
-              </a:spcAft>
-              <a:defRPr sz="2000">
-                <a:solidFill>
-                  <a:srgbClr val="1E1E1E"/>
-                </a:solidFill>
-                <a:latin typeface="Calibri"/>
-              </a:defRPr>
-            </a:pPr>
-            <a:r>
-              <a:t>• Synthetic data at 20 dB SNR: G₀ recovery within ±20% — sufficient for fibrosis staging</a:t>
-            </a:r>
-          </a:p>
-          <a:p>
-            <a:pPr>
-              <a:spcBef>
-                <a:spcPts val="1200"/>
-              </a:spcBef>
-              <a:spcAft>
-                <a:spcPts val="800"/>
-              </a:spcAft>
-              <a:defRPr sz="2000">
-                <a:solidFill>
-                  <a:srgbClr val="1E1E1E"/>
-                </a:solidFill>
-                <a:latin typeface="Calibri"/>
-              </a:defRPr>
-            </a:pPr>
-            <a:r>
-              <a:t>• MCMC convergence: 24.3–25.1% acceptance across three chains (optimal 20–30%)</a:t>
-            </a:r>
-          </a:p>
-          <a:p>
-            <a:pPr>
-              <a:spcBef>
-                <a:spcPts val="1200"/>
-              </a:spcBef>
-              <a:spcAft>
-                <a:spcPts val="800"/>
-              </a:spcAft>
-              <a:defRPr sz="2000">
-                <a:solidFill>
-                  <a:srgbClr val="1E1E1E"/>
-                </a:solidFill>
-                <a:latin typeface="Calibri"/>
-              </a:defRPr>
-            </a:pPr>
-            <a:r>
-              <a:t>• Posterior variance scales inversely with signal quality; minimum 25 dB SNR recommended</a:t>
-            </a:r>
-          </a:p>
-          <a:p>
-            <a:pPr>
-              <a:spcBef>
-                <a:spcPts val="1200"/>
-              </a:spcBef>
-              <a:spcAft>
-                <a:spcPts val="800"/>
-              </a:spcAft>
-              <a:defRPr sz="2000">
-                <a:solidFill>
-                  <a:srgbClr val="1E1E1E"/>
-                </a:solidFill>
-                <a:latin typeface="Calibri"/>
-              </a:defRPr>
-            </a:pPr>
-            <a:r>
-              <a:t>• 2D misfit landscapes quantify local curvature and guide phantom study protocols</a:t>
-            </a:r>
-          </a:p>
-          <a:p>
-            <a:pPr>
-              <a:spcBef>
-                <a:spcPts val="1200"/>
-              </a:spcBef>
-              <a:spcAft>
-                <a:spcPts val="800"/>
-              </a:spcAft>
-              <a:defRPr sz="2000">
-                <a:solidFill>
-                  <a:srgbClr val="1E1E1E"/>
-                </a:solidFill>
-                <a:latin typeface="Calibri"/>
-              </a:defRPr>
-            </a:pPr>
-            <a:r>
-              <a:t>• Experimental guidelines: λ/4 receiver spacing, 300–1200 Hz bandwidth, 0.5–2× corner frequency</a:t>
+            <a:pPr algn="ctr">
+              <a:defRPr sz="1400" i="1">
+                <a:solidFill>
+                  <a:srgbClr val="0096C7"/>
+                </a:solidFill>
+                <a:latin typeface="Calibri"/>
+              </a:defRPr>
+            </a:pPr>
+            <a:r>
+              <a:t>A. Parameter misfit landscape reveals G₀ is 3,000× more identifiable than G∞. B. Bayesian posterior gives credible intervals, not point estimates. C. G₀ recovery within ±20% at 20 dB SNR — sufficient for clinical fibrosis staging.</a:t>
             </a:r>
           </a:p>
         </p:txBody>

</xml_diff>